<commit_message>
Revert slide text to the pre-20px design
Restore es-slides.html to the original layout (before the 20px enlargement
and the follow-up overflow tweaks) and regenerate es-slides.pptx to match:
original font sizes and wording across all three slides.

Co-Authored-By: Claude Opus 4.8 <noreply@anthropic.com>
Claude-Session: https://claude.ai/code/session_01JqmwsYBiupBFvBy9YgEshe
</commit_message>
<xml_diff>
--- a/recruitment-slides/es-slides.pptx
+++ b/recruitment-slides/es-slides.pptx
@@ -3495,7 +3495,7 @@
               </a:spcAft>
             </a:pPr>
             <a:r>
-              <a:rPr sz="1700" b="0">
+              <a:rPr sz="1400" b="0">
                 <a:solidFill>
                   <a:srgbClr val="6B7683"/>
                 </a:solidFill>
@@ -3574,8 +3574,8 @@
         </p:nvSpPr>
         <p:spPr>
           <a:xfrm>
-            <a:off x="9646920" y="1481328"/>
-            <a:ext cx="1783080" cy="457200"/>
+            <a:off x="9829800" y="1517904"/>
+            <a:ext cx="1600200" cy="402336"/>
           </a:xfrm>
           <a:prstGeom prst="roundRect">
             <a:avLst/>
@@ -3618,8 +3618,8 @@
         </p:nvSpPr>
         <p:spPr>
           <a:xfrm>
-            <a:off x="9646920" y="1481328"/>
-            <a:ext cx="1783080" cy="457200"/>
+            <a:off x="9829800" y="1517904"/>
+            <a:ext cx="1600200" cy="402336"/>
           </a:xfrm>
           <a:prstGeom prst="rect">
             <a:avLst/>
@@ -3644,7 +3644,7 @@
               </a:spcAft>
             </a:pPr>
             <a:r>
-              <a:rPr sz="1500" b="1">
+              <a:rPr sz="1300" b="1">
                 <a:solidFill>
                   <a:srgbClr val="FFFFFF"/>
                 </a:solidFill>
@@ -3735,7 +3735,7 @@
               </a:spcAft>
             </a:pPr>
             <a:r>
-              <a:rPr sz="1700" b="1">
+              <a:rPr sz="1600" b="1">
                 <a:solidFill>
                   <a:srgbClr val="FFFFFF"/>
                 </a:solidFill>
@@ -3839,7 +3839,7 @@
               <a:t>●  </a:t>
             </a:r>
             <a:r>
-              <a:rPr sz="1600" b="0">
+              <a:rPr sz="1400" b="0">
                 <a:solidFill>
                   <a:srgbClr val="2B2F36"/>
                 </a:solidFill>
@@ -3847,10 +3847,10 @@
                 <a:ea typeface="Yu Gothic"/>
                 <a:cs typeface="Yu Gothic"/>
               </a:rPr>
-              <a:t>地域の </a:t>
-            </a:r>
-            <a:r>
-              <a:rPr sz="1600" b="1">
+              <a:t>地域コミュニティにおける</a:t>
+            </a:r>
+            <a:r>
+              <a:rPr sz="1400" b="1">
                 <a:solidFill>
                   <a:srgbClr val="1F7FC0"/>
                 </a:solidFill>
@@ -3861,7 +3861,7 @@
               <a:t>情報格差</a:t>
             </a:r>
             <a:r>
-              <a:rPr sz="1600" b="0">
+              <a:rPr sz="1400" b="0">
                 <a:solidFill>
                   <a:srgbClr val="2B2F36"/>
                 </a:solidFill>
@@ -3869,7 +3869,7 @@
                 <a:ea typeface="Yu Gothic"/>
                 <a:cs typeface="Yu Gothic"/>
               </a:rPr>
-              <a:t>をテーマに研究</a:t>
+              <a:t>の問題をテーマに研究</a:t>
             </a:r>
           </a:p>
           <a:p>
@@ -3896,7 +3896,7 @@
               <a:t>●  </a:t>
             </a:r>
             <a:r>
-              <a:rPr sz="1600" b="0">
+              <a:rPr sz="1400" b="0">
                 <a:solidFill>
                   <a:srgbClr val="2B2F36"/>
                 </a:solidFill>
@@ -3904,7 +3904,7 @@
                 <a:ea typeface="Yu Gothic"/>
                 <a:cs typeface="Yu Gothic"/>
               </a:rPr>
-              <a:t>「技術が人にどう使われるか」に着目</a:t>
+              <a:t>「技術が人にどう使われるか」という視点で調査・分析</a:t>
             </a:r>
           </a:p>
         </p:txBody>
@@ -3987,7 +3987,7 @@
               </a:spcAft>
             </a:pPr>
             <a:r>
-              <a:rPr sz="1700" b="1">
+              <a:rPr sz="1600" b="1">
                 <a:solidFill>
                   <a:srgbClr val="FFFFFF"/>
                 </a:solidFill>
@@ -4091,7 +4091,7 @@
               <a:t>●  </a:t>
             </a:r>
             <a:r>
-              <a:rPr sz="1600" b="0">
+              <a:rPr sz="1400" b="0">
                 <a:solidFill>
                   <a:srgbClr val="2B2F36"/>
                 </a:solidFill>
@@ -4099,7 +4099,7 @@
                 <a:ea typeface="Yu Gothic"/>
                 <a:cs typeface="Yu Gothic"/>
               </a:rPr>
-              <a:t>ITが生活を変える可能性を実感</a:t>
+              <a:t>ITツールが人々の生活を大きく変える可能性を実感</a:t>
             </a:r>
           </a:p>
           <a:p>
@@ -4126,7 +4126,7 @@
               <a:t>●  </a:t>
             </a:r>
             <a:r>
-              <a:rPr sz="1600" b="0">
+              <a:rPr sz="1400" b="0">
                 <a:solidFill>
                   <a:srgbClr val="2B2F36"/>
                 </a:solidFill>
@@ -4134,10 +4134,10 @@
                 <a:ea typeface="Yu Gothic"/>
                 <a:cs typeface="Yu Gothic"/>
               </a:rPr>
-              <a:t>「使う側」から </a:t>
-            </a:r>
-            <a:r>
-              <a:rPr sz="1600" b="1">
+              <a:t>「使う側」から</a:t>
+            </a:r>
+            <a:r>
+              <a:rPr sz="1400" b="1">
                 <a:solidFill>
                   <a:srgbClr val="1F7FC0"/>
                 </a:solidFill>
@@ -4148,7 +4148,7 @@
               <a:t>「作る側」</a:t>
             </a:r>
             <a:r>
-              <a:rPr sz="1600" b="0">
+              <a:rPr sz="1400" b="0">
                 <a:solidFill>
                   <a:srgbClr val="2B2F36"/>
                 </a:solidFill>
@@ -4156,7 +4156,7 @@
                 <a:ea typeface="Yu Gothic"/>
                 <a:cs typeface="Yu Gothic"/>
               </a:rPr>
-              <a:t>へ</a:t>
+              <a:t>へ回りたいと考えるように</a:t>
             </a:r>
           </a:p>
         </p:txBody>
@@ -4239,7 +4239,7 @@
               </a:spcAft>
             </a:pPr>
             <a:r>
-              <a:rPr sz="1700" b="1">
+              <a:rPr sz="1600" b="1">
                 <a:solidFill>
                   <a:srgbClr val="FFFFFF"/>
                 </a:solidFill>
@@ -4343,7 +4343,7 @@
               <a:t>●  </a:t>
             </a:r>
             <a:r>
-              <a:rPr sz="1600" b="0">
+              <a:rPr sz="1400" b="0">
                 <a:solidFill>
                   <a:srgbClr val="2B2F36"/>
                 </a:solidFill>
@@ -4351,10 +4351,10 @@
                 <a:ea typeface="Yu Gothic"/>
                 <a:cs typeface="Yu Gothic"/>
               </a:rPr>
-              <a:t>独学で </a:t>
-            </a:r>
-            <a:r>
-              <a:rPr sz="1600" b="1">
+              <a:t>独学で</a:t>
+            </a:r>
+            <a:r>
+              <a:rPr sz="1400" b="1">
                 <a:solidFill>
                   <a:srgbClr val="1F7FC0"/>
                 </a:solidFill>
@@ -4362,10 +4362,10 @@
                 <a:ea typeface="Yu Gothic"/>
                 <a:cs typeface="Yu Gothic"/>
               </a:rPr>
-              <a:t>プログラミング</a:t>
-            </a:r>
-            <a:r>
-              <a:rPr sz="1600" b="0">
+              <a:t>プログラミングの基礎</a:t>
+            </a:r>
+            <a:r>
+              <a:rPr sz="1400" b="0">
                 <a:solidFill>
                   <a:srgbClr val="2B2F36"/>
                 </a:solidFill>
@@ -4400,7 +4400,7 @@
               <a:t>●  </a:t>
             </a:r>
             <a:r>
-              <a:rPr sz="1600" b="0">
+              <a:rPr sz="1400" b="0">
                 <a:solidFill>
                   <a:srgbClr val="2B2F36"/>
                 </a:solidFill>
@@ -4408,7 +4408,7 @@
                 <a:ea typeface="Yu Gothic"/>
                 <a:cs typeface="Yu Gothic"/>
               </a:rPr>
-              <a:t>Python等で作業の自動化に挑戦</a:t>
+              <a:t>ExcelマクロやPythonで身近な作業の自動化に挑戦</a:t>
             </a:r>
           </a:p>
         </p:txBody>
@@ -4836,7 +4836,7 @@
               </a:spcAft>
             </a:pPr>
             <a:r>
-              <a:rPr sz="1500" b="1">
+              <a:rPr sz="1300" b="1">
                 <a:solidFill>
                   <a:srgbClr val="1F7FC0"/>
                 </a:solidFill>
@@ -5020,7 +5020,7 @@
               </a:spcAft>
             </a:pPr>
             <a:r>
-              <a:rPr sz="1700" b="1">
+              <a:rPr sz="1600" b="1">
                 <a:solidFill>
                   <a:srgbClr val="FFFFFF"/>
                 </a:solidFill>
@@ -5103,7 +5103,7 @@
           <a:p>
             <a:pPr algn="l">
               <a:lnSpc>
-                <a:spcPct val="140000"/>
+                <a:spcPct val="150000"/>
               </a:lnSpc>
               <a:spcBef>
                 <a:spcPts val="0"/>
@@ -5113,7 +5113,7 @@
               </a:spcAft>
             </a:pPr>
             <a:r>
-              <a:rPr sz="1700" b="0">
+              <a:rPr sz="1500" b="0">
                 <a:solidFill>
                   <a:srgbClr val="2B2F36"/>
                 </a:solidFill>
@@ -5121,35 +5121,13 @@
                 <a:ea typeface="Yu Gothic"/>
                 <a:cs typeface="Yu Gothic"/>
               </a:rPr>
-              <a:t>文系で培った</a:t>
-            </a:r>
-            <a:r>
-              <a:rPr sz="1700" b="1">
-                <a:solidFill>
-                  <a:srgbClr val="1F7FC0"/>
-                </a:solidFill>
-                <a:latin typeface="Yu Gothic"/>
-                <a:ea typeface="Yu Gothic"/>
-                <a:cs typeface="Yu Gothic"/>
-              </a:rPr>
-              <a:t>人間理解の視点</a:t>
-            </a:r>
-            <a:r>
-              <a:rPr sz="1700" b="0">
-                <a:solidFill>
-                  <a:srgbClr val="2B2F36"/>
-                </a:solidFill>
-                <a:latin typeface="Yu Gothic"/>
-                <a:ea typeface="Yu Gothic"/>
-                <a:cs typeface="Yu Gothic"/>
-              </a:rPr>
-              <a:t>を活かせるから。</a:t>
+              <a:t>文系で培った人間理解の視点を活かせるから。</a:t>
             </a:r>
           </a:p>
           <a:p>
             <a:pPr algn="l">
               <a:lnSpc>
-                <a:spcPct val="140000"/>
+                <a:spcPct val="150000"/>
               </a:lnSpc>
               <a:spcBef>
                 <a:spcPts val="0"/>
@@ -5159,7 +5137,7 @@
               </a:spcAft>
             </a:pPr>
             <a:r>
-              <a:rPr sz="1700" b="0">
+              <a:rPr sz="1500" b="0">
                 <a:solidFill>
                   <a:srgbClr val="2B2F36"/>
                 </a:solidFill>
@@ -5595,7 +5573,7 @@
               </a:spcAft>
             </a:pPr>
             <a:r>
-              <a:rPr sz="1500" b="1">
+              <a:rPr sz="1300" b="1">
                 <a:solidFill>
                   <a:srgbClr val="1F7FC0"/>
                 </a:solidFill>
@@ -5768,7 +5746,7 @@
               </a:spcAft>
             </a:pPr>
             <a:r>
-              <a:rPr sz="1700" b="1">
+              <a:rPr sz="1600" b="1">
                 <a:solidFill>
                   <a:srgbClr val="FFFFFF"/>
                 </a:solidFill>
@@ -5861,7 +5839,7 @@
               </a:spcAft>
             </a:pPr>
             <a:r>
-              <a:rPr sz="1700" b="0">
+              <a:rPr sz="1500" b="0">
                 <a:solidFill>
                   <a:srgbClr val="2B2F36"/>
                 </a:solidFill>
@@ -5869,10 +5847,10 @@
                 <a:ea typeface="Yu Gothic"/>
                 <a:cs typeface="Yu Gothic"/>
               </a:rPr>
-              <a:t>集計自動化で作業時間を </a:t>
-            </a:r>
-            <a:r>
-              <a:rPr sz="1700" b="1">
+              <a:t>集計自動化で作業時間を約</a:t>
+            </a:r>
+            <a:r>
+              <a:rPr sz="1500" b="1">
                 <a:solidFill>
                   <a:srgbClr val="1F7FC0"/>
                 </a:solidFill>
@@ -5880,10 +5858,10 @@
                 <a:ea typeface="Yu Gothic"/>
                 <a:cs typeface="Yu Gothic"/>
               </a:rPr>
-              <a:t>約6割削減</a:t>
-            </a:r>
-            <a:r>
-              <a:rPr sz="1700" b="0">
+              <a:t>6割削減</a:t>
+            </a:r>
+            <a:r>
+              <a:rPr sz="1500" b="0">
                 <a:solidFill>
                   <a:srgbClr val="2B2F36"/>
                 </a:solidFill>
@@ -5891,7 +5869,7 @@
                 <a:ea typeface="Yu Gothic"/>
                 <a:cs typeface="Yu Gothic"/>
               </a:rPr>
-              <a:t>。</a:t>
+              <a:t>した経験。</a:t>
             </a:r>
           </a:p>
           <a:p>
@@ -5907,7 +5885,7 @@
               </a:spcAft>
             </a:pPr>
             <a:r>
-              <a:rPr sz="1700" b="0">
+              <a:rPr sz="1500" b="0">
                 <a:solidFill>
                   <a:srgbClr val="2B2F36"/>
                 </a:solidFill>
@@ -5915,7 +5893,7 @@
                 <a:ea typeface="Yu Gothic"/>
                 <a:cs typeface="Yu Gothic"/>
               </a:rPr>
-              <a:t>工程を分解し、周囲を巻き込んで改善しました。</a:t>
+              <a:t>工程を分解し優先度順に着手、チームを巻き込んで改善しました。</a:t>
             </a:r>
           </a:p>
         </p:txBody>
@@ -5998,7 +5976,7 @@
               </a:spcAft>
             </a:pPr>
             <a:r>
-              <a:rPr sz="1700" b="1">
+              <a:rPr sz="1600" b="1">
                 <a:solidFill>
                   <a:srgbClr val="FFFFFF"/>
                 </a:solidFill>
@@ -6091,7 +6069,7 @@
               </a:spcAft>
             </a:pPr>
             <a:r>
-              <a:rPr sz="1700" b="0">
+              <a:rPr sz="1500" b="0">
                 <a:solidFill>
                   <a:srgbClr val="2B2F36"/>
                 </a:solidFill>
@@ -6099,7 +6077,7 @@
                 <a:ea typeface="Yu Gothic"/>
                 <a:cs typeface="Yu Gothic"/>
               </a:rPr>
-              <a:t>複雑な要件を構造化して開発に活かす。</a:t>
+              <a:t>複雑な要件を構造化し開発現場で活かす。</a:t>
             </a:r>
           </a:p>
           <a:p>
@@ -6115,7 +6093,7 @@
               </a:spcAft>
             </a:pPr>
             <a:r>
-              <a:rPr sz="1700" b="0">
+              <a:rPr sz="1500" b="0">
                 <a:solidFill>
                   <a:srgbClr val="2B2F36"/>
                 </a:solidFill>
@@ -6123,7 +6101,7 @@
                 <a:ea typeface="Yu Gothic"/>
                 <a:cs typeface="Yu Gothic"/>
               </a:rPr>
-              <a:t>対話で周囲を巻き込み、前進させます。</a:t>
+              <a:t>対話で周囲を巻き込み、使いやすいシステムづくりに貢献します。</a:t>
             </a:r>
           </a:p>
         </p:txBody>

</xml_diff>